<commit_message>
feat: POC avantages sportifs - pipeline complet
</commit_message>
<xml_diff>
--- a/docs/Choukri_Amal_Option_B_1_052026.pptx
+++ b/docs/Choukri_Amal_Option_B_1_052026.pptx
@@ -1957,6 +1957,11 @@
               </a:rPr>
               <a:t>par Amal Choukri</a:t>
             </a:r>
+            <a:endParaRPr lang="fr-FR" sz="1300" dirty="0">
+              <a:solidFill>
+                <a:srgbClr val="7AAFC8"/>
+              </a:solidFill>
+            </a:endParaRPr>
           </a:p>
           <a:p>
             <a:r>
@@ -1965,9 +1970,8 @@
                   <a:srgbClr val="7AAFC8"/>
                 </a:solidFill>
               </a:rPr>
-              <a:t>github.com/amalchoukri/sport-data-solution-poc</a:t>
-            </a:r>
-            <a:endParaRPr lang="fr-FR" sz="1300" noProof="0" dirty="0"/>
+              <a:t>https://github.com/AMAL82/sport-data-solution-poc.git</a:t>
+            </a:r>
           </a:p>
         </p:txBody>
       </p:sp>

</xml_diff>